<commit_message>
Save local work 2026-08-29 09:09
</commit_message>
<xml_diff>
--- a/VAVE Slide Files/VAVE-Slides-Generated.pptx
+++ b/VAVE Slide Files/VAVE-Slides-Generated.pptx
@@ -2,14 +2,14 @@
 <file path=ppt/presentation.xml><?xml version="1.0" encoding="utf-8"?>
 <p:presentation xmlns:p="http://schemas.openxmlformats.org/presentationml/2006/main">
   <p:sldMasterIdLst>
-    <p:sldMasterId xmlns:r="http://schemas.openxmlformats.org/officeDocument/2006/relationships" id="2147483648" r:id="R024b7691692344ec"/>
+    <p:sldMasterId xmlns:r="http://schemas.openxmlformats.org/officeDocument/2006/relationships" id="2147483648" r:id="R81143603ba8e4e2f"/>
   </p:sldMasterIdLst>
   <p:notesMasterIdLst>
-    <p:notesMasterId xmlns:r="http://schemas.openxmlformats.org/officeDocument/2006/relationships" r:id="R412da78686964ab3"/>
+    <p:notesMasterId xmlns:r="http://schemas.openxmlformats.org/officeDocument/2006/relationships" r:id="R0f5d67ad46ff40e6"/>
   </p:notesMasterIdLst>
   <p:sldIdLst>
-    <p:sldId xmlns:r="http://schemas.openxmlformats.org/officeDocument/2006/relationships" id="256" r:id="R55d144a78b6a4cc6"/>
-    <p:sldId xmlns:r="http://schemas.openxmlformats.org/officeDocument/2006/relationships" id="257" r:id="Rc9c92728990247e1"/>
+    <p:sldId xmlns:r="http://schemas.openxmlformats.org/officeDocument/2006/relationships" id="256" r:id="R9a54a2fbca0e4621"/>
+    <p:sldId xmlns:r="http://schemas.openxmlformats.org/officeDocument/2006/relationships" id="257" r:id="Rfcfc2d507e154bd8"/>
   </p:sldIdLst>
   <p:sldSz cx="12192000" cy="6858000"/>
   <p:notesSz cx="6858000" cy="9144000"/>
@@ -730,8 +730,8 @@
   </p:cSld>
   <p:clrMap bg1="lt1" tx1="dk1" bg2="lt2" tx2="dk2" accent1="accent1" accent2="accent2" accent3="accent3" accent4="accent4" accent5="accent5" accent6="accent6" hlink="hlink" folHlink="folHlink"/>
   <p:sldLayoutIdLst>
-    <p:sldLayoutId xmlns:r="http://schemas.openxmlformats.org/officeDocument/2006/relationships" id="2147483649" r:id="R185a880c06f2459e"/>
-    <p:sldLayoutId xmlns:r="http://schemas.openxmlformats.org/officeDocument/2006/relationships" id="2147483650" r:id="Rc04f965cd8f44bf7"/>
+    <p:sldLayoutId xmlns:r="http://schemas.openxmlformats.org/officeDocument/2006/relationships" id="2147483649" r:id="R80f2987931d04a3e"/>
+    <p:sldLayoutId xmlns:r="http://schemas.openxmlformats.org/officeDocument/2006/relationships" id="2147483650" r:id="Rf5db6b8235ca4531"/>
   </p:sldLayoutIdLst>
   <p:hf sldNum="0" hdr="0" ftr="0" dt="0"/>
   <p:txStyles>
@@ -5965,7 +5965,7 @@
           <p:cNvPr id="97" name="Generated Right Row 7">
             <a:extLst xmlns:a="http://schemas.openxmlformats.org/drawingml/2006/main">
               <a:ext uri="{FF2B5EF4-FFF2-40B4-BE49-F238E27FC236}">
-                <a16:creationId xmlns:a16="http://schemas.microsoft.com/office/drawing/2014/main" id="{FE4A94E6-0D09-4E27-8504-3FE06B2C5B68}"/>
+                <a16:creationId xmlns:a16="http://schemas.microsoft.com/office/drawing/2014/main" id="{E3755E44-F963-49A8-B09C-500B826AEB44}"/>
               </a:ext>
             </a:extLst>
           </p:cNvPr>
@@ -5998,7 +5998,7 @@
           <p:cNvPr id="98" name="Generated Right Task 7">
             <a:extLst xmlns:a="http://schemas.openxmlformats.org/drawingml/2006/main">
               <a:ext uri="{FF2B5EF4-FFF2-40B4-BE49-F238E27FC236}">
-                <a16:creationId xmlns:a16="http://schemas.microsoft.com/office/drawing/2014/main" id="{4A73104B-0ED4-422A-8447-A3EFABBB9869}"/>
+                <a16:creationId xmlns:a16="http://schemas.microsoft.com/office/drawing/2014/main" id="{F0B9547B-4769-446E-BB5D-057C89F9E98D}"/>
               </a:ext>
             </a:extLst>
           </p:cNvPr>
@@ -6047,7 +6047,7 @@
           <p:cNvPr id="99" name="Generated Right Savings 7">
             <a:extLst xmlns:a="http://schemas.openxmlformats.org/drawingml/2006/main">
               <a:ext uri="{FF2B5EF4-FFF2-40B4-BE49-F238E27FC236}">
-                <a16:creationId xmlns:a16="http://schemas.microsoft.com/office/drawing/2014/main" id="{6E6D311C-306F-4152-B55B-31F6B410B0A6}"/>
+                <a16:creationId xmlns:a16="http://schemas.microsoft.com/office/drawing/2014/main" id="{A1D84C52-0C23-40EE-B661-E04259F4E9B8}"/>
               </a:ext>
             </a:extLst>
           </p:cNvPr>
@@ -6096,7 +6096,7 @@
           <p:cNvPr id="100" name="Generated Right Date 7">
             <a:extLst xmlns:a="http://schemas.openxmlformats.org/drawingml/2006/main">
               <a:ext uri="{FF2B5EF4-FFF2-40B4-BE49-F238E27FC236}">
-                <a16:creationId xmlns:a16="http://schemas.microsoft.com/office/drawing/2014/main" id="{0BB42F30-EAA0-4D7E-8CFB-F8B2CE2252C4}"/>
+                <a16:creationId xmlns:a16="http://schemas.microsoft.com/office/drawing/2014/main" id="{3312E5B4-6779-4C5A-A20F-DC149C660001}"/>
               </a:ext>
             </a:extLst>
           </p:cNvPr>
@@ -6145,7 +6145,7 @@
           <p:cNvPr id="101" name="Generated Right Status Pill 7">
             <a:extLst xmlns:a="http://schemas.openxmlformats.org/drawingml/2006/main">
               <a:ext uri="{FF2B5EF4-FFF2-40B4-BE49-F238E27FC236}">
-                <a16:creationId xmlns:a16="http://schemas.microsoft.com/office/drawing/2014/main" id="{3C3323C6-DBD9-4377-8915-8EF007806E94}"/>
+                <a16:creationId xmlns:a16="http://schemas.microsoft.com/office/drawing/2014/main" id="{817091E7-9AC0-4B4A-94C0-6C3B6C7BD3A9}"/>
               </a:ext>
             </a:extLst>
           </p:cNvPr>
@@ -6180,7 +6180,7 @@
           <p:cNvPr id="102" name="Generated Right Status 7">
             <a:extLst xmlns:a="http://schemas.openxmlformats.org/drawingml/2006/main">
               <a:ext uri="{FF2B5EF4-FFF2-40B4-BE49-F238E27FC236}">
-                <a16:creationId xmlns:a16="http://schemas.microsoft.com/office/drawing/2014/main" id="{6518C32D-C1F4-4F7F-91D9-940004E1E82B}"/>
+                <a16:creationId xmlns:a16="http://schemas.microsoft.com/office/drawing/2014/main" id="{5E3F3761-097E-432D-B8A2-25433DCA72F8}"/>
               </a:ext>
             </a:extLst>
           </p:cNvPr>

</xml_diff>